<commit_message>
Update prototype screenshot across asset folder, presentation deck PPTX, and README featuring offline demo mode
</commit_message>
<xml_diff>
--- a/deck/GreenGuide_Project_Deck.pptx
+++ b/deck/GreenGuide_Project_Deck.pptx
@@ -6182,23 +6182,62 @@
           </a:ln>
         </p:spPr>
       </p:sp>
+      <p:sp>
+        <p:nvSpPr>
+          <p:cNvPr id="7" name="Text 4"/>
+          <p:cNvSpPr txBox="1"/>
+          <p:nvPr/>
+        </p:nvSpPr>
+        <p:spPr>
+          <a:xfrm>
+            <a:off x="11521440" y="6446520"/>
+            <a:ext cx="548640" cy="274320"/>
+          </a:xfrm>
+          <a:prstGeom prst="rect">
+            <a:avLst/>
+          </a:prstGeom>
+          <a:noFill/>
+          <a:ln/>
+        </p:spPr>
+        <p:txBody>
+          <a:bodyPr wrap="square" rtlCol="0" anchor="ctr"/>
+          <a:lstStyle/>
+          <a:p>
+            <a:pPr algn="r" indent="0" marL="0">
+              <a:buNone/>
+            </a:pPr>
+            <a:r>
+              <a:rPr lang="en-US" sz="1000" dirty="0">
+                <a:solidFill>
+                  <a:srgbClr val="4C5A45"/>
+                </a:solidFill>
+                <a:latin typeface="Calibri" pitchFamily="34" charset="0"/>
+                <a:ea typeface="Calibri" pitchFamily="34" charset="-122"/>
+                <a:cs typeface="Calibri" pitchFamily="34" charset="-120"/>
+              </a:rPr>
+              <a:t>08</a:t>
+            </a:r>
+            <a:endParaRPr lang="en-US" sz="1000" dirty="0"/>
+          </a:p>
+        </p:txBody>
+      </p:sp>
       <p:pic>
         <p:nvPicPr>
-          <p:cNvPr id="6" name="Image 0" descr="/home/claude/prototype_screenshot.png">    </p:cNvPr>
+          <p:cNvPr id="8" name="Picture 7" descr="prototype_screenshot.png"/>
           <p:cNvPicPr>
             <a:picLocks noChangeAspect="1"/>
           </p:cNvPicPr>
           <p:nvPr/>
         </p:nvPicPr>
         <p:blipFill>
-          <a:blip r:embed="rId1"/>
+          <a:blip r:embed="rId4"/>
           <a:stretch>
             <a:fillRect/>
           </a:stretch>
         </p:blipFill>
         <p:spPr>
           <a:xfrm>
-            <a:off x="2949832" y="1965960"/>
+            <a:off x="2949854" y="1965960"/>
             <a:ext cx="6289288" cy="4297680"/>
           </a:xfrm>
           <a:prstGeom prst="rect">
@@ -6206,45 +6245,6 @@
           </a:prstGeom>
         </p:spPr>
       </p:pic>
-      <p:sp>
-        <p:nvSpPr>
-          <p:cNvPr id="7" name="Text 4"/>
-          <p:cNvSpPr txBox="1"/>
-          <p:nvPr/>
-        </p:nvSpPr>
-        <p:spPr>
-          <a:xfrm>
-            <a:off x="11521440" y="6446520"/>
-            <a:ext cx="548640" cy="274320"/>
-          </a:xfrm>
-          <a:prstGeom prst="rect">
-            <a:avLst/>
-          </a:prstGeom>
-          <a:noFill/>
-          <a:ln/>
-        </p:spPr>
-        <p:txBody>
-          <a:bodyPr wrap="square" rtlCol="0" anchor="ctr"/>
-          <a:lstStyle/>
-          <a:p>
-            <a:pPr algn="r" indent="0" marL="0">
-              <a:buNone/>
-            </a:pPr>
-            <a:r>
-              <a:rPr lang="en-US" sz="1000" dirty="0">
-                <a:solidFill>
-                  <a:srgbClr val="4C5A45"/>
-                </a:solidFill>
-                <a:latin typeface="Calibri" pitchFamily="34" charset="0"/>
-                <a:ea typeface="Calibri" pitchFamily="34" charset="-122"/>
-                <a:cs typeface="Calibri" pitchFamily="34" charset="-120"/>
-              </a:rPr>
-              <a:t>08</a:t>
-            </a:r>
-            <a:endParaRPr lang="en-US" sz="1000" dirty="0"/>
-          </a:p>
-        </p:txBody>
-      </p:sp>
     </p:spTree>
   </p:cSld>
   <p:clrMapOvr>

</xml_diff>